<commit_message>
test(e2e): pin East Asian breaks to PowerPoint's own lines
The CJK line-breaking fixture grows from three boxes to twelve: a hanging
mark before a closing bracket (with kinsoku on and off) and breaks falling
between two differently formatted runs. Each box records the lines
PowerPoint produced (COM TextRange.Lines()), and the spec now compares every
binding's rendered lines with them instead of checking three characters.

Co-Authored-By: Claude Opus 5.5 (1M context) <noreply@anthropic.com>
Claude-Session: https://claude.ai/code/session_019SNjtp8WibuFkSPSc6oLJ9
</commit_message>
<xml_diff>
--- a/viewers/pptx/e2e/fixtures/cjk-line-breaking.pptx
+++ b/viewers/pptx/e2e/fixtures/cjk-line-breaking.pptx
@@ -407,8 +407,8 @@
         </p:nvSpPr>
         <p:spPr>
           <a:xfrm>
-            <a:off x="762000" y="762000"/>
-            <a:ext cx="1168400" cy="2032000"/>
+            <a:off x="508000" y="381000"/>
+            <a:ext cx="1168400" cy="1397000"/>
           </a:xfrm>
           <a:prstGeom prst="rect">
             <a:avLst/>
@@ -440,8 +440,8 @@
         </p:nvSpPr>
         <p:spPr>
           <a:xfrm>
-            <a:off x="3302000" y="762000"/>
-            <a:ext cx="1168400" cy="2032000"/>
+            <a:off x="3429000" y="381000"/>
+            <a:ext cx="1168400" cy="1397000"/>
           </a:xfrm>
           <a:prstGeom prst="rect">
             <a:avLst/>
@@ -473,8 +473,8 @@
         </p:nvSpPr>
         <p:spPr>
           <a:xfrm>
-            <a:off x="5842000" y="762000"/>
-            <a:ext cx="1168400" cy="2032000"/>
+            <a:off x="6350000" y="381000"/>
+            <a:ext cx="1168400" cy="1397000"/>
           </a:xfrm>
           <a:prstGeom prst="rect">
             <a:avLst/>
@@ -494,6 +494,360 @@
                 <a:ea typeface="Yu Gothic"/>
               </a:rPr>
               <a:t>あいうえ」たちつて</a:t>
+            </a:r>
+          </a:p>
+        </p:txBody>
+      </p:sp>
+      <p:sp>
+        <p:nvSpPr>
+          <p:cNvPr id="5" name="XBREAK"/>
+          <p:cNvSpPr txBox="1"/>
+          <p:nvPr/>
+        </p:nvSpPr>
+        <p:spPr>
+          <a:xfrm>
+            <a:off x="9271000" y="381000"/>
+            <a:ext cx="1168400" cy="1397000"/>
+          </a:xfrm>
+          <a:prstGeom prst="rect">
+            <a:avLst/>
+          </a:prstGeom>
+          <a:noFill/>
+        </p:spPr>
+        <p:txBody>
+          <a:bodyPr wrap="square" lIns="0" tIns="0" rIns="0" bIns="0">
+            <a:noAutofit/>
+          </a:bodyPr>
+          <a:lstStyle/>
+          <a:p>
+            <a:pPr hangingPunct="0" eaLnBrk="0"/>
+            <a:r>
+              <a:rPr lang="ja-JP" sz="2000" dirty="0">
+                <a:latin typeface="Yu Gothic"/>
+                <a:ea typeface="Yu Gothic"/>
+              </a:rPr>
+              <a:t>まみむめ</a:t>
+            </a:r>
+            <a:r>
+              <a:rPr lang="ja-JP" sz="2000" dirty="0">
+                <a:solidFill>
+                  <a:srgbClr val="C00000"/>
+                </a:solidFill>
+                <a:latin typeface="Yu Gothic"/>
+                <a:ea typeface="Yu Gothic"/>
+              </a:rPr>
+              <a:t>」やゆよわ</a:t>
+            </a:r>
+          </a:p>
+        </p:txBody>
+      </p:sp>
+      <p:sp>
+        <p:nvSpPr>
+          <p:cNvPr id="6" name="XBREAK_KANA"/>
+          <p:cNvSpPr txBox="1"/>
+          <p:nvPr/>
+        </p:nvSpPr>
+        <p:spPr>
+          <a:xfrm>
+            <a:off x="508000" y="2413000"/>
+            <a:ext cx="1168400" cy="1397000"/>
+          </a:xfrm>
+          <a:prstGeom prst="rect">
+            <a:avLst/>
+          </a:prstGeom>
+          <a:noFill/>
+        </p:spPr>
+        <p:txBody>
+          <a:bodyPr wrap="square" lIns="0" tIns="0" rIns="0" bIns="0">
+            <a:noAutofit/>
+          </a:bodyPr>
+          <a:lstStyle/>
+          <a:p>
+            <a:pPr hangingPunct="0" eaLnBrk="0"/>
+            <a:r>
+              <a:rPr lang="ja-JP" sz="2000" dirty="0">
+                <a:latin typeface="Yu Gothic"/>
+                <a:ea typeface="Yu Gothic"/>
+              </a:rPr>
+              <a:t>さしすせ</a:t>
+            </a:r>
+            <a:r>
+              <a:rPr lang="ja-JP" sz="2000" b="1" dirty="0">
+                <a:latin typeface="Yu Gothic"/>
+                <a:ea typeface="Yu Gothic"/>
+              </a:rPr>
+              <a:t>ょそたち</a:t>
+            </a:r>
+          </a:p>
+        </p:txBody>
+      </p:sp>
+      <p:sp>
+        <p:nvSpPr>
+          <p:cNvPr id="7" name="XKINSOKU"/>
+          <p:cNvSpPr txBox="1"/>
+          <p:nvPr/>
+        </p:nvSpPr>
+        <p:spPr>
+          <a:xfrm>
+            <a:off x="3429000" y="2413000"/>
+            <a:ext cx="1168400" cy="1397000"/>
+          </a:xfrm>
+          <a:prstGeom prst="rect">
+            <a:avLst/>
+          </a:prstGeom>
+          <a:noFill/>
+        </p:spPr>
+        <p:txBody>
+          <a:bodyPr wrap="square" lIns="0" tIns="0" rIns="0" bIns="0">
+            <a:noAutofit/>
+          </a:bodyPr>
+          <a:lstStyle/>
+          <a:p>
+            <a:pPr hangingPunct="0" eaLnBrk="1"/>
+            <a:r>
+              <a:rPr lang="ja-JP" sz="2000" dirty="0">
+                <a:latin typeface="Yu Gothic"/>
+                <a:ea typeface="Yu Gothic"/>
+              </a:rPr>
+              <a:t>なにぬね</a:t>
+            </a:r>
+            <a:r>
+              <a:rPr lang="ja-JP" sz="2000" dirty="0">
+                <a:solidFill>
+                  <a:srgbClr val="C00000"/>
+                </a:solidFill>
+                <a:latin typeface="Yu Gothic"/>
+                <a:ea typeface="Yu Gothic"/>
+              </a:rPr>
+              <a:t>」はひふへ</a:t>
+            </a:r>
+          </a:p>
+        </p:txBody>
+      </p:sp>
+      <p:sp>
+        <p:nvSpPr>
+          <p:cNvPr id="8" name="XHANG_START"/>
+          <p:cNvSpPr txBox="1"/>
+          <p:nvPr/>
+        </p:nvSpPr>
+        <p:spPr>
+          <a:xfrm>
+            <a:off x="6350000" y="2413000"/>
+            <a:ext cx="1168400" cy="1397000"/>
+          </a:xfrm>
+          <a:prstGeom prst="rect">
+            <a:avLst/>
+          </a:prstGeom>
+          <a:noFill/>
+        </p:spPr>
+        <p:txBody>
+          <a:bodyPr wrap="square" lIns="0" tIns="0" rIns="0" bIns="0">
+            <a:noAutofit/>
+          </a:bodyPr>
+          <a:lstStyle/>
+          <a:p>
+            <a:pPr hangingPunct="1" eaLnBrk="1"/>
+            <a:r>
+              <a:rPr lang="ja-JP" sz="2000" dirty="0">
+                <a:latin typeface="Yu Gothic"/>
+                <a:ea typeface="Yu Gothic"/>
+              </a:rPr>
+              <a:t>らりるれ</a:t>
+            </a:r>
+            <a:r>
+              <a:rPr lang="ja-JP" sz="2000" dirty="0">
+                <a:solidFill>
+                  <a:srgbClr val="C00000"/>
+                </a:solidFill>
+                <a:latin typeface="Yu Gothic"/>
+                <a:ea typeface="Yu Gothic"/>
+              </a:rPr>
+              <a:t>。をんあい</a:t>
+            </a:r>
+          </a:p>
+        </p:txBody>
+      </p:sp>
+      <p:sp>
+        <p:nvSpPr>
+          <p:cNvPr id="9" name="XHANG_END"/>
+          <p:cNvSpPr txBox="1"/>
+          <p:nvPr/>
+        </p:nvSpPr>
+        <p:spPr>
+          <a:xfrm>
+            <a:off x="9271000" y="2413000"/>
+            <a:ext cx="1168400" cy="1397000"/>
+          </a:xfrm>
+          <a:prstGeom prst="rect">
+            <a:avLst/>
+          </a:prstGeom>
+          <a:noFill/>
+        </p:spPr>
+        <p:txBody>
+          <a:bodyPr wrap="square" lIns="0" tIns="0" rIns="0" bIns="0">
+            <a:noAutofit/>
+          </a:bodyPr>
+          <a:lstStyle/>
+          <a:p>
+            <a:pPr hangingPunct="1" eaLnBrk="1"/>
+            <a:r>
+              <a:rPr lang="ja-JP" sz="2000" dirty="0">
+                <a:latin typeface="Yu Gothic"/>
+                <a:ea typeface="Yu Gothic"/>
+              </a:rPr>
+              <a:t>がぎぐげ。</a:t>
+            </a:r>
+            <a:r>
+              <a:rPr lang="ja-JP" sz="2000" dirty="0">
+                <a:solidFill>
+                  <a:srgbClr val="C00000"/>
+                </a:solidFill>
+                <a:latin typeface="Yu Gothic"/>
+                <a:ea typeface="Yu Gothic"/>
+              </a:rPr>
+              <a:t>ざじずぜ</a:t>
+            </a:r>
+          </a:p>
+        </p:txBody>
+      </p:sp>
+      <p:sp>
+        <p:nvSpPr>
+          <p:cNvPr id="10" name="HANG_BRACKET"/>
+          <p:cNvSpPr txBox="1"/>
+          <p:nvPr/>
+        </p:nvSpPr>
+        <p:spPr>
+          <a:xfrm>
+            <a:off x="508000" y="4445000"/>
+            <a:ext cx="1168400" cy="1397000"/>
+          </a:xfrm>
+          <a:prstGeom prst="rect">
+            <a:avLst/>
+          </a:prstGeom>
+          <a:noFill/>
+        </p:spPr>
+        <p:txBody>
+          <a:bodyPr wrap="square" lIns="0" tIns="0" rIns="0" bIns="0">
+            <a:noAutofit/>
+          </a:bodyPr>
+          <a:lstStyle/>
+          <a:p>
+            <a:pPr hangingPunct="1" eaLnBrk="1"/>
+            <a:r>
+              <a:rPr lang="ja-JP" sz="2000" dirty="0">
+                <a:latin typeface="Yu Gothic"/>
+                <a:ea typeface="Yu Gothic"/>
+              </a:rPr>
+              <a:t>かきくけ。」こさし</a:t>
+            </a:r>
+          </a:p>
+        </p:txBody>
+      </p:sp>
+      <p:sp>
+        <p:nvSpPr>
+          <p:cNvPr id="11" name="HANG_TEN_BRACKET"/>
+          <p:cNvSpPr txBox="1"/>
+          <p:nvPr/>
+        </p:nvSpPr>
+        <p:spPr>
+          <a:xfrm>
+            <a:off x="3429000" y="4445000"/>
+            <a:ext cx="1168400" cy="1397000"/>
+          </a:xfrm>
+          <a:prstGeom prst="rect">
+            <a:avLst/>
+          </a:prstGeom>
+          <a:noFill/>
+        </p:spPr>
+        <p:txBody>
+          <a:bodyPr wrap="square" lIns="0" tIns="0" rIns="0" bIns="0">
+            <a:noAutofit/>
+          </a:bodyPr>
+          <a:lstStyle/>
+          <a:p>
+            <a:pPr hangingPunct="1" eaLnBrk="1"/>
+            <a:r>
+              <a:rPr lang="ja-JP" sz="2000" dirty="0">
+                <a:latin typeface="Yu Gothic"/>
+                <a:ea typeface="Yu Gothic"/>
+              </a:rPr>
+              <a:t>たちつて、」となに</a:t>
+            </a:r>
+          </a:p>
+        </p:txBody>
+      </p:sp>
+      <p:sp>
+        <p:nvSpPr>
+          <p:cNvPr id="12" name="XHANG_BRACKET"/>
+          <p:cNvSpPr txBox="1"/>
+          <p:nvPr/>
+        </p:nvSpPr>
+        <p:spPr>
+          <a:xfrm>
+            <a:off x="6350000" y="4445000"/>
+            <a:ext cx="1168400" cy="1397000"/>
+          </a:xfrm>
+          <a:prstGeom prst="rect">
+            <a:avLst/>
+          </a:prstGeom>
+          <a:noFill/>
+        </p:spPr>
+        <p:txBody>
+          <a:bodyPr wrap="square" lIns="0" tIns="0" rIns="0" bIns="0">
+            <a:noAutofit/>
+          </a:bodyPr>
+          <a:lstStyle/>
+          <a:p>
+            <a:pPr hangingPunct="1" eaLnBrk="1"/>
+            <a:r>
+              <a:rPr lang="ja-JP" sz="2000" dirty="0">
+                <a:latin typeface="Yu Gothic"/>
+                <a:ea typeface="Yu Gothic"/>
+              </a:rPr>
+              <a:t>ばびぶべ。</a:t>
+            </a:r>
+            <a:r>
+              <a:rPr lang="ja-JP" sz="2000" dirty="0">
+                <a:solidFill>
+                  <a:srgbClr val="C00000"/>
+                </a:solidFill>
+                <a:latin typeface="Yu Gothic"/>
+                <a:ea typeface="Yu Gothic"/>
+              </a:rPr>
+              <a:t>」ぼぱぴ</a:t>
+            </a:r>
+          </a:p>
+        </p:txBody>
+      </p:sp>
+      <p:sp>
+        <p:nvSpPr>
+          <p:cNvPr id="13" name="HANG_BRACKET_ANYWHERE"/>
+          <p:cNvSpPr txBox="1"/>
+          <p:nvPr/>
+        </p:nvSpPr>
+        <p:spPr>
+          <a:xfrm>
+            <a:off x="9271000" y="4445000"/>
+            <a:ext cx="1168400" cy="1397000"/>
+          </a:xfrm>
+          <a:prstGeom prst="rect">
+            <a:avLst/>
+          </a:prstGeom>
+          <a:noFill/>
+        </p:spPr>
+        <p:txBody>
+          <a:bodyPr wrap="square" lIns="0" tIns="0" rIns="0" bIns="0">
+            <a:noAutofit/>
+          </a:bodyPr>
+          <a:lstStyle/>
+          <a:p>
+            <a:pPr hangingPunct="1" eaLnBrk="0"/>
+            <a:r>
+              <a:rPr lang="ja-JP" sz="2000" dirty="0">
+                <a:latin typeface="Yu Gothic"/>
+                <a:ea typeface="Yu Gothic"/>
+              </a:rPr>
+              <a:t>はひふへ。」ほまみ</a:t>
             </a:r>
           </a:p>
         </p:txBody>

</xml_diff>